<commit_message>
Presentation PowerPoint : images reelles + contenu detaille (pas generique)
- 15 diapositives (PNJ/dialogue separe en diapo propre)
- 6 images du projet integrees (captures Play mode + frames video) :
  les deux scenes, troupeau Ankole, interaction, PNJ, demo video
- Contenu reecrit pour etre specifique : noms de fichiers/scripts reels,
  auteurs et licences exactes des assets, versions d'outils, description
  technique precise des bugs rencontres (pas de formulation generique)
- Correction d'un chevauchement texte/images sur la diapo des deux scenes

🤖 Generated with [Claude Code](https://claude.com/claude-code)

Co-Authored-By: Claude Sonnet 5 <noreply@anthropic.com>
</commit_message>
<xml_diff>
--- a/docs/Livrable_4/Wuro-et-Galle-Presentation.pptx
+++ b/docs/Livrable_4/Wuro-et-Galle-Presentation.pptx
@@ -2,7 +2,7 @@
 <file path=docProps\app.xml><?xml version="1.0" encoding="utf-8"?>
 <Properties xmlns="http://schemas.openxmlformats.org/officeDocument/2006/extended-properties" xmlns:vt="http://schemas.openxmlformats.org/officeDocument/2006/docPropsVTypes">
   <Application>Microsoft Office PowerPoint</Application>
-  <Slides>14</Slides>
+  <Slides>15</Slides>
 </Properties>
 </file>
 
@@ -33,6 +33,7 @@
     <p:sldId id="267" r:id="rIdSlide12"/>
     <p:sldId id="268" r:id="rIdSlide13"/>
     <p:sldId id="269" r:id="rIdSlide14"/>
+    <p:sldId id="270" r:id="rIdSlide15"/>
   </p:sldIdLst>
   <p:sldSz cx="12192000" cy="6858000" type="screen16x9"/>
   <p:notesSz cx="6858000" cy="9144000"/>
@@ -284,7 +285,7 @@
                   <a:srgbClr val="6B3E1E"/>
                 </a:solidFill>
               </a:rPr>
-              <a:t>Ambiance et immersion</a:t>
+              <a:t>PNJ et dialogue vocal</a:t>
             </a:r>
           </a:p>
         </p:txBody>
@@ -301,45 +302,74 @@
         </p:nvSpPr>
         <p:spPr>
           <a:xfrm>
-            <a:off x="838200" y="1700000"/>
-            <a:ext cx="10515600" cy="4700000"/>
-          </a:xfrm>
-        </p:spPr>
-        <p:txBody>
-          <a:bodyPr/>
-          <a:lstStyle/>
-          <a:p>
-            <a:pPr marL="342900" indent="-342900">
-              <a:buFont typeface="Arial"/>
-              <a:buChar char="-u{2022}-"/>
-            </a:pPr>
-            <a:r>
-              <a:rPr lang="fr-FR" sz="2400" dirty="0"/>
-              <a:t>Terrain avec relief jusqu'a l'horizon, brouillard, poussiere, nuages en deplacement</a:t>
-            </a:r>
-          </a:p>
-          <a:p>
-            <a:pPr marL="342900" indent="-342900">
-              <a:buFont typeface="Arial"/>
-              <a:buChar char="-u{2022}-"/>
-            </a:pPr>
-            <a:r>
-              <a:rPr lang="fr-FR" sz="2400" dirty="0"/>
-              <a:t>Audio spatialise : feu, clochettes, troupeau au paturage, vent, appel a la priere</a:t>
-            </a:r>
-          </a:p>
-          <a:p>
-            <a:pPr marL="342900" indent="-342900">
-              <a:buFont typeface="Arial"/>
-              <a:buChar char="-u{2022}-"/>
-            </a:pPr>
-            <a:r>
-              <a:rPr lang="fr-FR" sz="2400" dirty="0"/>
-              <a:t>Eclairage dynamique (cycle aube-zenith-crepuscule) sur la scene principale</a:t>
-            </a:r>
-          </a:p>
-        </p:txBody>
-      </p:sp>
+            <a:off x="457200" y="1700000"/>
+            <a:ext cx="5486400" cy="4800000"/>
+          </a:xfrm>
+        </p:spPr>
+        <p:txBody>
+          <a:bodyPr/>
+          <a:lstStyle/>
+          <a:p>
+            <a:pPr marL="285750" indent="-285750">
+              <a:buFont typeface="Arial"/>
+              <a:buChar char="•"/>
+            </a:pPr>
+            <a:r>
+              <a:rPr lang="fr-FR" sz="1700" dirty="0"/>
+              <a:t>2 PNJ : le berger (Campement) et la femme peule (Concession), silhouettes habillees sans traits individualises</a:t>
+            </a:r>
+          </a:p>
+          <a:p>
+            <a:pPr marL="285750" indent="-285750">
+              <a:buFont typeface="Arial"/>
+              <a:buChar char="•"/>
+            </a:pPr>
+            <a:r>
+              <a:rPr lang="fr-FR" sz="1700" dirty="0"/>
+              <a:t>3 lignes audio par PNJ (berger_01-03 / femme_01-03), assignation automatique par prefixe de nom</a:t>
+            </a:r>
+          </a:p>
+          <a:p>
+            <a:pPr marL="285750" indent="-285750">
+              <a:buFont typeface="Arial"/>
+              <a:buChar char="•"/>
+            </a:pPr>
+            <a:r>
+              <a:rPr lang="fr-FR" sz="1700" dirty="0"/>
+              <a:t>Premiere passe en synthese vocale (Windows OneCore, faute de micro disponible), lignes finales re-enregistrees par l'utilisateur et re-assignees</a:t>
+            </a:r>
+          </a:p>
+        </p:txBody>
+      </p:sp>
+      <p:pic>
+        <p:nvPicPr>
+          <p:cNvPr id="10" name="Picture"/>
+          <p:cNvPicPr>
+            <a:picLocks noChangeAspect="1"/>
+          </p:cNvPicPr>
+          <p:nvPr/>
+        </p:nvPicPr>
+        <p:blipFill>
+          <a:blip r:embed="rIdImg1"/>
+          <a:stretch>
+            <a:fillRect/>
+          </a:stretch>
+        </p:blipFill>
+        <p:spPr>
+          <a:xfrm>
+            <a:off x="6200775" y="1900000"/>
+            <a:ext cx="5486400" cy="3086550"/>
+          </a:xfrm>
+          <a:prstGeom prst="rect">
+            <a:avLst/>
+          </a:prstGeom>
+          <a:ln w="19050">
+            <a:solidFill>
+              <a:srgbClr val="6B3E1E"/>
+            </a:solidFill>
+          </a:ln>
+        </p:spPr>
+      </p:pic>
     </p:spTree>
   </p:cSld>
   <p:clrMapOvr>
@@ -391,7 +421,7 @@
                   <a:srgbClr val="6B3E1E"/>
                 </a:solidFill>
               </a:rPr>
-              <a:t>Defis techniques rencontres</a:t>
+              <a:t>Ambiance et immersion</a:t>
             </a:r>
           </a:p>
         </p:txBody>
@@ -418,31 +448,31 @@
           <a:p>
             <a:pPr marL="342900" indent="-342900">
               <a:buFont typeface="Arial"/>
-              <a:buChar char="-u{2022}-"/>
-            </a:pPr>
-            <a:r>
-              <a:rPr lang="fr-FR" sz="2400" dirty="0"/>
-              <a:t>Bug GameObject.Find : recherche cross-scene silencieuse (corrige par une recherche limitee a la scene active)</a:t>
-            </a:r>
-          </a:p>
-          <a:p>
-            <a:pPr marL="342900" indent="-342900">
-              <a:buFont typeface="Arial"/>
-              <a:buChar char="-u{2022}-"/>
-            </a:pPr>
-            <a:r>
-              <a:rPr lang="fr-FR" sz="2400" dirty="0"/>
-              <a:t>Limite silencieuse de l'export glTF : materiaux procoduraux complexes non supportes, retombent en blanc</a:t>
-            </a:r>
-          </a:p>
-          <a:p>
-            <a:pPr marL="342900" indent="-342900">
-              <a:buFont typeface="Arial"/>
-              <a:buChar char="-u{2022}-"/>
-            </a:pPr>
-            <a:r>
-              <a:rPr lang="fr-FR" sz="2400" dirty="0"/>
-              <a:t>Ce sprint : position reelle de l'enclos (conversion d'axe Blender -&gt; Unity), materiau du zebu, hauteur du joueur, bug de camera desactivee</a:t>
+              <a:buChar char="•"/>
+            </a:pPr>
+            <a:r>
+              <a:rPr lang="fr-FR" sz="2000" dirty="0"/>
+              <a:t>Terrain avec relief reel (bruit applique jusqu'au bord, pas de plateau plat), brouillard de distance, poussiere en suspension, nuages en deplacement</a:t>
+            </a:r>
+          </a:p>
+          <a:p>
+            <a:pPr marL="342900" indent="-342900">
+              <a:buFont typeface="Arial"/>
+              <a:buChar char="•"/>
+            </a:pPr>
+            <a:r>
+              <a:rPr lang="fr-FR" sz="2000" dirty="0"/>
+              <a:t>Audio spatialise (freesound.org, CC0) : feu (kyles), clochettes (schmutz), troupeau au paturage (davorl), vent (felix.blume), appel a la priere (martineerok)</a:t>
+            </a:r>
+          </a:p>
+          <a:p>
+            <a:pPr marL="342900" indent="-342900">
+              <a:buFont typeface="Arial"/>
+              <a:buChar char="•"/>
+            </a:pPr>
+            <a:r>
+              <a:rPr lang="fr-FR" sz="2000" dirty="0"/>
+              <a:t>Eclairage dynamique (cycle aube-zenith-crepuscule) sur le Campement, post-processing partage entre les deux scenes</a:t>
             </a:r>
           </a:p>
         </p:txBody>
@@ -498,7 +528,7 @@
                   <a:srgbClr val="6B3E1E"/>
                 </a:solidFill>
               </a:rPr>
-              <a:t>Limites assumees</a:t>
+              <a:t>Defis techniques rencontres</a:t>
             </a:r>
           </a:p>
         </p:txBody>
@@ -525,31 +555,31 @@
           <a:p>
             <a:pPr marL="342900" indent="-342900">
               <a:buFont typeface="Arial"/>
-              <a:buChar char="-u{2022}-"/>
-            </a:pPr>
-            <a:r>
-              <a:rPr lang="fr-FR" sz="2400" dirty="0"/>
-              <a:t>Pas de casque VR disponible : integration desktop complete et testee, rig XR differe</a:t>
-            </a:r>
-          </a:p>
-          <a:p>
-            <a:pPr marL="342900" indent="-342900">
-              <a:buFont typeface="Arial"/>
-              <a:buChar char="-u{2022}-"/>
-            </a:pPr>
-            <a:r>
-              <a:rPr lang="fr-FR" sz="2400" dirty="0"/>
-              <a:t>Validation communautaire des usages domestiques non obtenue dans le delai - sources academiques croisees a la place</a:t>
-            </a:r>
-          </a:p>
-          <a:p>
-            <a:pPr marL="342900" indent="-342900">
-              <a:buFont typeface="Arial"/>
-              <a:buChar char="-u{2022}-"/>
-            </a:pPr>
-            <a:r>
-              <a:rPr lang="fr-FR" sz="2400" dirty="0"/>
-              <a:t>Scope volontairement reduit et documente plutot qu'un rendu bacle sur l'ensemble</a:t>
+              <a:buChar char="•"/>
+            </a:pPr>
+            <a:r>
+              <a:rPr lang="fr-FR" sz="2000" dirty="0"/>
+              <a:t>GameObject.Find recherche dans toutes les scenes chargees simultanement (noms d'objets identiques entre Campement/Concession) - corrige par une recherche limitee aux racines de la scene active</a:t>
+            </a:r>
+          </a:p>
+          <a:p>
+            <a:pPr marL="342900" indent="-342900">
+              <a:buFont typeface="Arial"/>
+              <a:buChar char="•"/>
+            </a:pPr>
+            <a:r>
+              <a:rPr lang="fr-FR" sz="2000" dirty="0"/>
+              <a:t>Export glTF : graphes de materiaux procoduraux complexes (bruit -&gt; rampe -&gt; melange) non supportes, retombent en blanc silencieusement - corrige en n'utilisant que texture image sur UV reels ou couleur plate</a:t>
+            </a:r>
+          </a:p>
+          <a:p>
+            <a:pPr marL="342900" indent="-342900">
+              <a:buFont typeface="Arial"/>
+              <a:buChar char="•"/>
+            </a:pPr>
+            <a:r>
+              <a:rPr lang="fr-FR" sz="2000" dirty="0"/>
+              <a:t>Ce sprint : texture 'metallic' du zebu quasi blanche -&gt; bete rendue metallique grise/noire ; enclos mal place (axe X inverse Blender-&gt;Unity, mesure par raycast) ; script de pose attache par erreur sur le mauvais objet -&gt; desactivait la camera en Play mode</a:t>
             </a:r>
           </a:p>
         </p:txBody>
@@ -605,7 +635,7 @@
                   <a:srgbClr val="6B3E1E"/>
                 </a:solidFill>
               </a:rPr>
-              <a:t>Demonstration video</a:t>
+              <a:t>Limites assumees</a:t>
             </a:r>
           </a:p>
         </p:txBody>
@@ -632,31 +662,31 @@
           <a:p>
             <a:pPr marL="342900" indent="-342900">
               <a:buFont typeface="Arial"/>
-              <a:buChar char="-u{2022}-"/>
-            </a:pPr>
-            <a:r>
-              <a:rPr lang="fr-FR" sz="2400" dirty="0"/>
-              <a:t>Parcours filme des deux scenes (Campement + Concession), environ 6min30</a:t>
-            </a:r>
-          </a:p>
-          <a:p>
-            <a:pPr marL="342900" indent="-342900">
-              <a:buFont typeface="Arial"/>
-              <a:buChar char="-u{2022}-"/>
-            </a:pPr>
-            <a:r>
-              <a:rPr lang="fr-FR" sz="2400" dirty="0"/>
-              <a:t>Ambiance sonore, PNJ et dialogue, interactions disponibles annotees a l'ecran</a:t>
-            </a:r>
-          </a:p>
-          <a:p>
-            <a:pPr marL="342900" indent="-342900">
-              <a:buFont typeface="Arial"/>
-              <a:buChar char="-u{2022}-"/>
-            </a:pPr>
-            <a:r>
-              <a:rPr lang="fr-FR" sz="2400" dirty="0"/>
-              <a:t>(voir wuro-galle-flythrough.mp4)</a:t>
+              <a:buChar char="•"/>
+            </a:pPr>
+            <a:r>
+              <a:rPr lang="fr-FR" sz="2000" dirty="0"/>
+              <a:t>Pas de casque VR disponible pendant le projet -&gt; integration desktop complete et testee, rig XR et build APK differes</a:t>
+            </a:r>
+          </a:p>
+          <a:p>
+            <a:pPr marL="342900" indent="-342900">
+              <a:buFont typeface="Arial"/>
+              <a:buChar char="•"/>
+            </a:pPr>
+            <a:r>
+              <a:rPr lang="fr-FR" sz="2000" dirty="0"/>
+              <a:t>Validation communautaire des usages domestiques precis non obtenue dans le delai -&gt; sources academiques croisees plutot qu'une autorite unique</a:t>
+            </a:r>
+          </a:p>
+          <a:p>
+            <a:pPr marL="342900" indent="-342900">
+              <a:buFont typeface="Arial"/>
+              <a:buChar char="•"/>
+            </a:pPr>
+            <a:r>
+              <a:rPr lang="fr-FR" sz="2000" dirty="0"/>
+              <a:t>Licence exacte du modele Ankole Cattle non confirmee avec certitude (tracee jusqu'a la collection Sketchfab de l'auteur, page precise non retrouvee)</a:t>
             </a:r>
           </a:p>
         </p:txBody>
@@ -712,6 +742,142 @@
                   <a:srgbClr val="6B3E1E"/>
                 </a:solidFill>
               </a:rPr>
+              <a:t>Demonstration video</a:t>
+            </a:r>
+          </a:p>
+        </p:txBody>
+      </p:sp>
+      <p:sp>
+        <p:nvSpPr>
+          <p:cNvPr id="3" name="Content"/>
+          <p:cNvSpPr>
+            <a:spLocks noGrp="1"/>
+          </p:cNvSpPr>
+          <p:nvPr>
+            <p:ph type="body" idx="1"/>
+          </p:nvPr>
+        </p:nvSpPr>
+        <p:spPr>
+          <a:xfrm>
+            <a:off x="457200" y="1700000"/>
+            <a:ext cx="5486400" cy="4800000"/>
+          </a:xfrm>
+        </p:spPr>
+        <p:txBody>
+          <a:bodyPr/>
+          <a:lstStyle/>
+          <a:p>
+            <a:pPr marL="285750" indent="-285750">
+              <a:buFont typeface="Arial"/>
+              <a:buChar char="•"/>
+            </a:pPr>
+            <a:r>
+              <a:rPr lang="fr-FR" sz="1700" dirty="0"/>
+              <a:t>wuro-galle-flythrough.mp4 : 6 min 30, parcours cameras scriptees des deux scenes</a:t>
+            </a:r>
+          </a:p>
+          <a:p>
+            <a:pPr marL="285750" indent="-285750">
+              <a:buFont typeface="Arial"/>
+              <a:buChar char="•"/>
+            </a:pPr>
+            <a:r>
+              <a:rPr lang="fr-FR" sz="1700" dirty="0"/>
+              <a:t>Bande son : ambiance, appel a la priere, voix des PNJ, sous-titres d'interaction synchronises</a:t>
+            </a:r>
+          </a:p>
+          <a:p>
+            <a:pPr marL="285750" indent="-285750">
+              <a:buFont typeface="Arial"/>
+              <a:buChar char="•"/>
+            </a:pPr>
+            <a:r>
+              <a:rPr lang="fr-FR" sz="1700" dirty="0"/>
+              <a:t>Verifie image par image et niveau audio sur toute la duree avant livraison</a:t>
+            </a:r>
+          </a:p>
+        </p:txBody>
+      </p:sp>
+      <p:pic>
+        <p:nvPicPr>
+          <p:cNvPr id="10" name="Picture"/>
+          <p:cNvPicPr>
+            <a:picLocks noChangeAspect="1"/>
+          </p:cNvPicPr>
+          <p:nvPr/>
+        </p:nvPicPr>
+        <p:blipFill>
+          <a:blip r:embed="rIdImg1"/>
+          <a:stretch>
+            <a:fillRect/>
+          </a:stretch>
+        </p:blipFill>
+        <p:spPr>
+          <a:xfrm>
+            <a:off x="6200775" y="1900000"/>
+            <a:ext cx="5486400" cy="3086550"/>
+          </a:xfrm>
+          <a:prstGeom prst="rect">
+            <a:avLst/>
+          </a:prstGeom>
+          <a:ln w="19050">
+            <a:solidFill>
+              <a:srgbClr val="6B3E1E"/>
+            </a:solidFill>
+          </a:ln>
+        </p:spPr>
+      </p:pic>
+    </p:spTree>
+  </p:cSld>
+  <p:clrMapOvr>
+    <a:overrideClrMapping bg1="lt1" tx1="dk1" bg2="lt2" tx2="dk2" accent1="accent1" accent2="accent2" accent3="accent3" accent4="accent4" accent5="accent5" accent6="accent6" hlink="hlink" folHlink="folHlink"/>
+  </p:clrMapOvr>
+</p:sld>
+</file>
+
+<file path=ppt\slides\slide15.xml><?xml version="1.0" encoding="utf-8"?>
+<p:sld xmlns:a="http://schemas.openxmlformats.org/drawingml/2006/main" xmlns:r="http://schemas.openxmlformats.org/officeDocument/2006/relationships" xmlns:p="http://schemas.openxmlformats.org/presentationml/2006/main">
+  <p:cSld>
+    <p:spTree>
+      <p:nvGrpSpPr>
+        <p:cNvPr id="1" name=""/>
+        <p:cNvGrpSpPr/>
+        <p:nvPr/>
+      </p:nvGrpSpPr>
+      <p:grpSpPr>
+        <a:xfrm>
+          <a:off x="0" y="0"/>
+          <a:ext cx="0" cy="0"/>
+          <a:chOff x="0" y="0"/>
+          <a:chExt cx="0" cy="0"/>
+        </a:xfrm>
+      </p:grpSpPr>
+      <p:sp>
+        <p:nvSpPr>
+          <p:cNvPr id="2" name="Title"/>
+          <p:cNvSpPr>
+            <a:spLocks noGrp="1"/>
+          </p:cNvSpPr>
+          <p:nvPr>
+            <p:ph type="title"/>
+          </p:nvPr>
+        </p:nvSpPr>
+        <p:spPr>
+          <a:xfrm>
+            <a:off x="838200" y="457200"/>
+            <a:ext cx="10515600" cy="1000000"/>
+          </a:xfrm>
+        </p:spPr>
+        <p:txBody>
+          <a:bodyPr/>
+          <a:lstStyle/>
+          <a:p>
+            <a:r>
+              <a:rPr lang="fr-FR" sz="3200" b="1" dirty="0">
+                <a:solidFill>
+                  <a:srgbClr val="6B3E1E"/>
+                </a:solidFill>
+              </a:rPr>
               <a:t>Conclusion et perspectives</a:t>
             </a:r>
           </a:p>
@@ -739,31 +905,31 @@
           <a:p>
             <a:pPr marL="342900" indent="-342900">
               <a:buFont typeface="Arial"/>
-              <a:buChar char="-u{2022}-"/>
-            </a:pPr>
-            <a:r>
-              <a:rPr lang="fr-FR" sz="2400" dirty="0"/>
-              <a:t>Livrable reduit en ambition visuelle par rapport au cahier des charges initial, mais coherent et honnete sur ses choix</a:t>
-            </a:r>
-          </a:p>
-          <a:p>
-            <a:pPr marL="342900" indent="-342900">
-              <a:buFont typeface="Arial"/>
-              <a:buChar char="-u{2022}-"/>
-            </a:pPr>
-            <a:r>
-              <a:rPr lang="fr-FR" sz="2400" dirty="0"/>
-              <a:t>Rigueur documentaire et coherence culturelle maintenues jusqu'au bout</a:t>
-            </a:r>
-          </a:p>
-          <a:p>
-            <a:pPr marL="342900" indent="-342900">
-              <a:buFont typeface="Arial"/>
-              <a:buChar char="-u{2022}-"/>
-            </a:pPr>
-            <a:r>
-              <a:rPr lang="fr-FR" sz="2400" dirty="0"/>
-              <a:t>Perspectives : integration XR complete, validation communautaire, enrichissement du troupeau et des PNJ</a:t>
+              <a:buChar char="•"/>
+            </a:pPr>
+            <a:r>
+              <a:rPr lang="fr-FR" sz="2000" dirty="0"/>
+              <a:t>Livrable reduit en ambition visuelle face au cahier des charges initial, mais coherent et honnete sur ses choix (chaque arbitrage documente)</a:t>
+            </a:r>
+          </a:p>
+          <a:p>
+            <a:pPr marL="342900" indent="-342900">
+              <a:buFont typeface="Arial"/>
+              <a:buChar char="•"/>
+            </a:pPr>
+            <a:r>
+              <a:rPr lang="fr-FR" sz="2000" dirty="0"/>
+              <a:t>Rigueur documentaire et coherence culturelle maintenues jusqu'au bout, y compris en revenant sur une fonctionnalite (Terrain procedural) puis en la reprenant corrigee</a:t>
+            </a:r>
+          </a:p>
+          <a:p>
+            <a:pPr marL="342900" indent="-342900">
+              <a:buFont typeface="Arial"/>
+              <a:buChar char="•"/>
+            </a:pPr>
+            <a:r>
+              <a:rPr lang="fr-FR" sz="2000" dirty="0"/>
+              <a:t>Perspectives : integration XR complete, retour communautaire sur les usages domestiques, troupeau et PNJ enrichis</a:t>
             </a:r>
           </a:p>
         </p:txBody>
@@ -846,31 +1012,31 @@
           <a:p>
             <a:pPr marL="342900" indent="-342900">
               <a:buFont typeface="Arial"/>
-              <a:buChar char="-u{2022}-"/>
-            </a:pPr>
-            <a:r>
-              <a:rPr lang="fr-FR" sz="2400" dirty="0"/>
-              <a:t>Environnement 3D/VR (desktop, clavier-souris ; XR differe faute de casque disponible)</a:t>
-            </a:r>
-          </a:p>
-          <a:p>
-            <a:pPr marL="342900" indent="-342900">
-              <a:buFont typeface="Arial"/>
-              <a:buChar char="-u{2022}-"/>
-            </a:pPr>
-            <a:r>
-              <a:rPr lang="fr-FR" sz="2400" dirty="0"/>
-              <a:t>Representer deux espaces peuls : le Wuro (campement nomade) et la Galle (concession sedentaire)</a:t>
-            </a:r>
-          </a:p>
-          <a:p>
-            <a:pPr marL="342900" indent="-342900">
-              <a:buFont typeface="Arial"/>
-              <a:buChar char="-u{2022}-"/>
-            </a:pPr>
-            <a:r>
-              <a:rPr lang="fr-FR" sz="2400" dirty="0"/>
-              <a:t>Objectif pedagogique : comprendre l'organisation spatiale et les codes culturels peuls (pulaaku)</a:t>
+              <a:buChar char="•"/>
+            </a:pPr>
+            <a:r>
+              <a:rPr lang="fr-FR" sz="2000" dirty="0"/>
+              <a:t>Environnement 3D interactif desktop (clavier/souris) - XR Interaction Toolkit installe mais integration differee : aucun casque Quest 2/3 disponible pendant le projet</a:t>
+            </a:r>
+          </a:p>
+          <a:p>
+            <a:pPr marL="342900" indent="-342900">
+              <a:buFont typeface="Arial"/>
+              <a:buChar char="•"/>
+            </a:pPr>
+            <a:r>
+              <a:rPr lang="fr-FR" sz="2000" dirty="0"/>
+              <a:t>Deux espaces peuls modelises : le Wuro (campement nomade, 2 suudu) et la Galle (concession sedentaire, 3 cases + dudal + grenier)</a:t>
+            </a:r>
+          </a:p>
+          <a:p>
+            <a:pPr marL="342900" indent="-342900">
+              <a:buFont typeface="Arial"/>
+              <a:buChar char="•"/>
+            </a:pPr>
+            <a:r>
+              <a:rPr lang="fr-FR" sz="2000" dirty="0"/>
+              <a:t>Objectif du module (Arts et Humanites Numeriques) : restituer l'organisation spatiale et les codes culturels peuls (pulaaku) dans un environnement navigable, pas seulement illustratif</a:t>
             </a:r>
           </a:p>
         </p:txBody>
@@ -953,31 +1119,41 @@
           <a:p>
             <a:pPr marL="342900" indent="-342900">
               <a:buFont typeface="Arial"/>
-              <a:buChar char="-u{2022}-"/>
-            </a:pPr>
-            <a:r>
-              <a:rPr lang="fr-FR" sz="2400" dirty="0"/>
-              <a:t>Cahier des charges pense pour un groupe de 3, realise seul, en moins d'un mois, sans GPU dedie</a:t>
-            </a:r>
-          </a:p>
-          <a:p>
-            <a:pPr marL="342900" indent="-342900">
-              <a:buFont typeface="Arial"/>
-              <a:buChar char="-u{2022}-"/>
-            </a:pPr>
-            <a:r>
-              <a:rPr lang="fr-FR" sz="2400" dirty="0"/>
-              <a:t>Scope reduit et documente : 2 suudu, 3 cases + dudal + grenier, cycle aube-zenith-crepuscule</a:t>
-            </a:r>
-          </a:p>
-          <a:p>
-            <a:pPr marL="342900" indent="-342900">
-              <a:buFont typeface="Arial"/>
-              <a:buChar char="-u{2022}-"/>
-            </a:pPr>
-            <a:r>
-              <a:rPr lang="fr-FR" sz="2400" dirty="0"/>
-              <a:t>Deux axes non negociables : rigueur documentaire et coherence culturelle (25% + 15% de la grille)</a:t>
+              <a:buChar char="•"/>
+            </a:pPr>
+            <a:r>
+              <a:rPr lang="fr-FR" sz="2000" dirty="0"/>
+              <a:t>Cahier des charges initial : travail de groupe de 3 personnes sur un semestre</a:t>
+            </a:r>
+          </a:p>
+          <a:p>
+            <a:pPr marL="342900" indent="-342900">
+              <a:buFont typeface="Arial"/>
+              <a:buChar char="•"/>
+            </a:pPr>
+            <a:r>
+              <a:rPr lang="fr-FR" sz="2000" dirty="0"/>
+              <a:t>Realise seul, en moins d'un mois, sur un poste sans GPU dedie (rendus Blender/Unity en CPU, verifications par exports batch)</a:t>
+            </a:r>
+          </a:p>
+          <a:p>
+            <a:pPr marL="342900" indent="-342900">
+              <a:buFont typeface="Arial"/>
+              <a:buChar char="•"/>
+            </a:pPr>
+            <a:r>
+              <a:rPr lang="fr-FR" sz="2000" dirty="0"/>
+              <a:t>Scope reduit et documente (scope-reduit.md) : 2 suudu (pas 3-4), 3 cases (pas 5-6), cycle aube-zenith-crepuscule (pas de nuit etoilee), une seule scene approfondie (eclairage dynamique + feu + audio spatialise)</a:t>
+            </a:r>
+          </a:p>
+          <a:p>
+            <a:pPr marL="342900" indent="-342900">
+              <a:buFont typeface="Arial"/>
+              <a:buChar char="•"/>
+            </a:pPr>
+            <a:r>
+              <a:rPr lang="fr-FR" sz="2000" dirty="0"/>
+              <a:t>Deux criteres non negociables dans la grille d'evaluation : rigueur documentaire (25%) et coherence symbolique (15%)</a:t>
             </a:r>
           </a:p>
         </p:txBody>
@@ -1060,31 +1236,31 @@
           <a:p>
             <a:pPr marL="342900" indent="-342900">
               <a:buFont typeface="Arial"/>
-              <a:buChar char="-u{2022}-"/>
-            </a:pPr>
-            <a:r>
-              <a:rPr lang="fr-FR" sz="2400" dirty="0"/>
-              <a:t>Personnages : silhouettes stylisees, sans traits du visage individualises</a:t>
-            </a:r>
-          </a:p>
-          <a:p>
-            <a:pPr marL="342900" indent="-342900">
-              <a:buFont typeface="Arial"/>
-              <a:buChar char="-u{2022}-"/>
-            </a:pPr>
-            <a:r>
-              <a:rPr lang="fr-FR" sz="2400" dirty="0"/>
-              <a:t>Organisation spatiale public/prive respectee (gradient entree - espace commun - prive)</a:t>
-            </a:r>
-          </a:p>
-          <a:p>
-            <a:pPr marL="342900" indent="-342900">
-              <a:buFont typeface="Arial"/>
-              <a:buChar char="-u{2022}-"/>
-            </a:pPr>
-            <a:r>
-              <a:rPr lang="fr-FR" sz="2400" dirty="0"/>
-              <a:t>Biais de sources evite : le Gerewol (Niger, tres photogenique) surrepresente mais hors-sujet face a la vie pastorale quotidienne du Diamare camerounais</a:t>
+              <a:buChar char="•"/>
+            </a:pPr>
+            <a:r>
+              <a:rPr lang="fr-FR" sz="2000" dirty="0"/>
+              <a:t>Personnages : silhouettes stylisees sans traits du visage individualises (base humaine CC0 'Human Basemeshes', treesclimber, OpenGameArt.org) - pas une economie de moyens, un choix : individualiser reviendrait a representer des personnes reelles ou composites sans consentement</a:t>
+            </a:r>
+          </a:p>
+          <a:p>
+            <a:pPr marL="342900" indent="-342900">
+              <a:buFont typeface="Arial"/>
+              <a:buChar char="•"/>
+            </a:pPr>
+            <a:r>
+              <a:rPr lang="fr-FR" sz="2000" dirty="0"/>
+              <a:t>Organisation spatiale : gradient entree-publique / interieur-prive respecte (chaque case orientee porte vers l'espace commun ou l'entree, jamais au hasard)</a:t>
+            </a:r>
+          </a:p>
+          <a:p>
+            <a:pPr marL="342900" indent="-342900">
+              <a:buFont typeface="Arial"/>
+              <a:buChar char="•"/>
+            </a:pPr>
+            <a:r>
+              <a:rPr lang="fr-FR" sz="2000" dirty="0"/>
+              <a:t>Biais de source ecarte activement : le Gerewol des Wodaabe (Niger), tres photogenique et surrepresente dans l'imaginaire occidental, mais sans rapport avec la vie pastorale quotidienne du Diamare camerounais documentee ici</a:t>
             </a:r>
           </a:p>
         </p:txBody>
@@ -1167,31 +1343,31 @@
           <a:p>
             <a:pPr marL="342900" indent="-342900">
               <a:buFont typeface="Arial"/>
-              <a:buChar char="-u{2022}-"/>
-            </a:pPr>
-            <a:r>
-              <a:rPr lang="fr-FR" sz="2400" dirty="0"/>
-              <a:t>Corpus documentaire, glossaire fulfulde-francais, schema spatial annote suudu/galle - chaque terme sourcee</a:t>
-            </a:r>
-          </a:p>
-          <a:p>
-            <a:pPr marL="342900" indent="-342900">
-              <a:buFont typeface="Arial"/>
-              <a:buChar char="-u{2022}-"/>
-            </a:pPr>
-            <a:r>
-              <a:rPr lang="fr-FR" sz="2400" dirty="0"/>
-              <a:t>Donnees non confirmees marquees explicitement comme hypotheses, jamais presentees comme certaines</a:t>
-            </a:r>
-          </a:p>
-          <a:p>
-            <a:pPr marL="342900" indent="-342900">
-              <a:buFont typeface="Arial"/>
-              <a:buChar char="-u{2022}-"/>
-            </a:pPr>
-            <a:r>
-              <a:rPr lang="fr-FR" sz="2400" dirty="0"/>
-              <a:t>Licences verifiees (CC0 / CC-BY) et attribution systematique pour chaque asset externe</a:t>
+              <a:buChar char="•"/>
+            </a:pPr>
+            <a:r>
+              <a:rPr lang="fr-FR" sz="2000" dirty="0"/>
+              <a:t>corpus-documentaire.md : chaque source (texte, image, modele 3D, son) reliee a une reference verifiable et une licence (CC0 ou CC-BY-4.0), attribution systematique meme quand la licence ne l'exige pas</a:t>
+            </a:r>
+          </a:p>
+          <a:p>
+            <a:pPr marL="342900" indent="-342900">
+              <a:buFont typeface="Arial"/>
+              <a:buChar char="•"/>
+            </a:pPr>
+            <a:r>
+              <a:rPr lang="fr-FR" sz="2000" dirty="0"/>
+              <a:t>glossaire-fulfulde-francais.md et schema-annote-suudu-galle.md sources - le terme 'seygoore' (natte tressee) signale explicitement comme non retrouve tel quel plutot que remplace en silence</a:t>
+            </a:r>
+          </a:p>
+          <a:p>
+            <a:pPr marL="342900" indent="-342900">
+              <a:buFont typeface="Arial"/>
+              <a:buChar char="•"/>
+            </a:pPr>
+            <a:r>
+              <a:rPr lang="fr-FR" sz="2000" dirty="0"/>
+              <a:t>Donnees non confirmees (distances precises, orientation cardinale exacte) marquees 'hypothese', jamais presentees avec la meme autorite que les elements reellement sources</a:t>
             </a:r>
           </a:p>
         </p:txBody>
@@ -1274,31 +1450,31 @@
           <a:p>
             <a:pPr marL="342900" indent="-342900">
               <a:buFont typeface="Arial"/>
-              <a:buChar char="-u{2022}-"/>
-            </a:pPr>
-            <a:r>
-              <a:rPr lang="fr-FR" sz="2400" dirty="0"/>
-              <a:t>Modelisation procedurale sous Blender (Python / bpy) -&gt; export glTF -&gt; import Unity</a:t>
-            </a:r>
-          </a:p>
-          <a:p>
-            <a:pPr marL="342900" indent="-342900">
-              <a:buFont typeface="Arial"/>
-              <a:buChar char="-u{2022}-"/>
-            </a:pPr>
-            <a:r>
-              <a:rPr lang="fr-FR" sz="2400" dirty="0"/>
-              <a:t>Assemblage de scene entierement scripte (SceneBuilder.cs) : reproductible, pas d'edition manuelle figee</a:t>
-            </a:r>
-          </a:p>
-          <a:p>
-            <a:pPr marL="342900" indent="-342900">
-              <a:buFont typeface="Arial"/>
-              <a:buChar char="-u{2022}-"/>
-            </a:pPr>
-            <a:r>
-              <a:rPr lang="fr-FR" sz="2400" dirty="0"/>
-              <a:t>Verification automatisee : rendu batch headless, tests Play mode, captures de controle a chaque etape</a:t>
+              <a:buChar char="•"/>
+            </a:pPr>
+            <a:r>
+              <a:rPr lang="fr-FR" sz="2000" dirty="0"/>
+              <a:t>Modelisation procedurale sous Blender 4.1 (Python / bpy, aucune modelisation manuelle a la souris) -&gt; export glTF/GLB -&gt; import Unity 2022.3.62f1 (Built-in Render Pipeline)</a:t>
+            </a:r>
+          </a:p>
+          <a:p>
+            <a:pPr marL="342900" indent="-342900">
+              <a:buFont typeface="Arial"/>
+              <a:buChar char="•"/>
+            </a:pPr>
+            <a:r>
+              <a:rPr lang="fr-FR" sz="2000" dirty="0"/>
+              <a:t>Assemblage de scene 100% scripte (SceneBuilder.cs) : les deux scenes sont reconstruites depuis zero par un seul menu ('Pipeline complet'), jamais editees a la main de facon irreproductible</a:t>
+            </a:r>
+          </a:p>
+          <a:p>
+            <a:pPr marL="342900" indent="-342900">
+              <a:buFont typeface="Arial"/>
+              <a:buChar char="•"/>
+            </a:pPr>
+            <a:r>
+              <a:rPr lang="fr-FR" sz="2000" dirty="0"/>
+              <a:t>Verification systematique : rendu batch headless (-batchmode -executeMethod), tests Play mode automatises (PlayModeSmokeTest.cs, capture + comptage d'erreurs), captures de controle avant chaque validation</a:t>
             </a:r>
           </a:p>
         </p:txBody>
@@ -1340,8 +1516,8 @@
         </p:nvSpPr>
         <p:spPr>
           <a:xfrm>
-            <a:off x="838200" y="457200"/>
-            <a:ext cx="10515600" cy="1000000"/>
+            <a:off x="838200" y="228600"/>
+            <a:ext cx="10515600" cy="800000"/>
           </a:xfrm>
         </p:spPr>
         <p:txBody>
@@ -1359,6 +1535,118 @@
           </a:p>
         </p:txBody>
       </p:sp>
+      <p:pic>
+        <p:nvPicPr>
+          <p:cNvPr id="10" name="Picture1"/>
+          <p:cNvPicPr>
+            <a:picLocks noChangeAspect="1"/>
+          </p:cNvPicPr>
+          <p:nvPr/>
+        </p:nvPicPr>
+        <p:blipFill>
+          <a:blip r:embed="rIdImg1"/>
+          <a:stretch>
+            <a:fillRect/>
+          </a:stretch>
+        </p:blipFill>
+        <p:spPr>
+          <a:xfrm>
+            <a:off x="457200" y="1200000"/>
+            <a:ext cx="5486400" cy="3085200"/>
+          </a:xfrm>
+          <a:prstGeom prst="rect">
+            <a:avLst/>
+          </a:prstGeom>
+          <a:ln w="19050">
+            <a:solidFill>
+              <a:srgbClr val="6B3E1E"/>
+            </a:solidFill>
+          </a:ln>
+        </p:spPr>
+      </p:pic>
+      <p:pic>
+        <p:nvPicPr>
+          <p:cNvPr id="11" name="Picture2"/>
+          <p:cNvPicPr>
+            <a:picLocks noChangeAspect="1"/>
+          </p:cNvPicPr>
+          <p:nvPr/>
+        </p:nvPicPr>
+        <p:blipFill>
+          <a:blip r:embed="rIdImg2"/>
+          <a:stretch>
+            <a:fillRect/>
+          </a:stretch>
+        </p:blipFill>
+        <p:spPr>
+          <a:xfrm>
+            <a:off x="6248400" y="1200000"/>
+            <a:ext cx="5486400" cy="3085200"/>
+          </a:xfrm>
+          <a:prstGeom prst="rect">
+            <a:avLst/>
+          </a:prstGeom>
+          <a:ln w="19050">
+            <a:solidFill>
+              <a:srgbClr val="6B3E1E"/>
+            </a:solidFill>
+          </a:ln>
+        </p:spPr>
+      </p:pic>
+      <p:sp>
+        <p:nvSpPr>
+          <p:cNvPr id="12" name="Cap1"/>
+          <p:cNvSpPr txBox="1"/>
+          <p:nvPr/>
+        </p:nvSpPr>
+        <p:spPr>
+          <a:xfrm>
+            <a:off x="457200" y="4320000"/>
+            <a:ext cx="5486400" cy="350000"/>
+          </a:xfrm>
+          <a:prstGeom prst="rect">
+            <a:avLst/>
+          </a:prstGeom>
+        </p:spPr>
+        <p:txBody>
+          <a:bodyPr/>
+          <a:lstStyle/>
+          <a:p>
+            <a:pPr algn="ctr"/>
+            <a:r>
+              <a:rPr lang="fr-FR" sz="1400" b="1" i="1" dirty="0"/>
+              <a:t>Campement (Wuro)</a:t>
+            </a:r>
+          </a:p>
+        </p:txBody>
+      </p:sp>
+      <p:sp>
+        <p:nvSpPr>
+          <p:cNvPr id="13" name="Cap2"/>
+          <p:cNvSpPr txBox="1"/>
+          <p:nvPr/>
+        </p:nvSpPr>
+        <p:spPr>
+          <a:xfrm>
+            <a:off x="6248400" y="4320000"/>
+            <a:ext cx="5486400" cy="350000"/>
+          </a:xfrm>
+          <a:prstGeom prst="rect">
+            <a:avLst/>
+          </a:prstGeom>
+        </p:spPr>
+        <p:txBody>
+          <a:bodyPr/>
+          <a:lstStyle/>
+          <a:p>
+            <a:pPr algn="ctr"/>
+            <a:r>
+              <a:rPr lang="fr-FR" sz="1400" b="1" i="1" dirty="0"/>
+              <a:t>Concession (Galle)</a:t>
+            </a:r>
+          </a:p>
+        </p:txBody>
+      </p:sp>
       <p:sp>
         <p:nvSpPr>
           <p:cNvPr id="3" name="Content"/>
@@ -1371,41 +1659,41 @@
         </p:nvSpPr>
         <p:spPr>
           <a:xfrm>
-            <a:off x="838200" y="1700000"/>
-            <a:ext cx="10515600" cy="4700000"/>
-          </a:xfrm>
-        </p:spPr>
-        <p:txBody>
-          <a:bodyPr/>
-          <a:lstStyle/>
-          <a:p>
-            <a:pPr marL="342900" indent="-342900">
-              <a:buFont typeface="Arial"/>
-              <a:buChar char="-u{2022}-"/>
-            </a:pPr>
-            <a:r>
-              <a:rPr lang="fr-FR" sz="2400" dirty="0"/>
-              <a:t>Campement (Wuro) : 2 suudu, foyer central, enclos a betail, vegetation sahelienne</a:t>
-            </a:r>
-          </a:p>
-          <a:p>
-            <a:pPr marL="342900" indent="-342900">
-              <a:buFont typeface="Arial"/>
-              <a:buChar char="-u{2022}-"/>
-            </a:pPr>
-            <a:r>
-              <a:rPr lang="fr-FR" sz="2400" dirty="0"/>
-              <a:t>Concession (Galle) : 3 cases (galle), dudal (priere), grenier, enclos</a:t>
-            </a:r>
-          </a:p>
-          <a:p>
-            <a:pPr marL="342900" indent="-342900">
-              <a:buFont typeface="Arial"/>
-              <a:buChar char="-u{2022}-"/>
-            </a:pPr>
-            <a:r>
-              <a:rPr lang="fr-FR" sz="2400" dirty="0"/>
-              <a:t>Organisation spatiale fidele au gradient public/prive documente dans le corpus</a:t>
+            <a:off x="457200" y="5050000"/>
+            <a:ext cx="11277600" cy="1650000"/>
+          </a:xfrm>
+        </p:spPr>
+        <p:txBody>
+          <a:bodyPr/>
+          <a:lstStyle/>
+          <a:p>
+            <a:pPr marL="285750" indent="-285750">
+              <a:buFont typeface="Arial"/>
+              <a:buChar char="•"/>
+            </a:pPr>
+            <a:r>
+              <a:rPr lang="fr-FR" sz="1600" dirty="0"/>
+              <a:t>Campement : 2 suudu, foyer central (feu anime + lumiere scintillante), enclos a betail (7 tetes), vegetation sahelienne, terrain avec relief et brouillard jusqu'a l'horizon</a:t>
+            </a:r>
+          </a:p>
+          <a:p>
+            <a:pPr marL="285750" indent="-285750">
+              <a:buFont typeface="Arial"/>
+              <a:buChar char="•"/>
+            </a:pPr>
+            <a:r>
+              <a:rPr lang="fr-FR" sz="1600" dirty="0"/>
+              <a:t>Concession : 3 cases, dudal (priere, ecarte pour l'intimite), grenier surleve avec foyer secondaire, enclos a betail (4 tetes)</a:t>
+            </a:r>
+          </a:p>
+          <a:p>
+            <a:pPr marL="285750" indent="-285750">
+              <a:buFont typeface="Arial"/>
+              <a:buChar char="•"/>
+            </a:pPr>
+            <a:r>
+              <a:rPr lang="fr-FR" sz="1600" dirty="0"/>
+              <a:t>Les deux scenes partagent le meme terrain (hoggo/enclos, mare) mais different par le mobilier et l'agencement des habitations</a:t>
             </a:r>
           </a:p>
         </p:txBody>
@@ -1478,45 +1766,74 @@
         </p:nvSpPr>
         <p:spPr>
           <a:xfrm>
-            <a:off x="838200" y="1700000"/>
-            <a:ext cx="10515600" cy="4700000"/>
-          </a:xfrm>
-        </p:spPr>
-        <p:txBody>
-          <a:bodyPr/>
-          <a:lstStyle/>
-          <a:p>
-            <a:pPr marL="342900" indent="-342900">
-              <a:buFont typeface="Arial"/>
-              <a:buChar char="-u{2022}-"/>
-            </a:pPr>
-            <a:r>
-              <a:rPr lang="fr-FR" sz="2400" dirty="0"/>
-              <a:t>Personnage joueur et PNJ : base humaine CC0, habilles (boubou, chapeau de paille, foulard)</a:t>
-            </a:r>
-          </a:p>
-          <a:p>
-            <a:pPr marL="342900" indent="-342900">
-              <a:buFont typeface="Arial"/>
-              <a:buChar char="-u{2022}-"/>
-            </a:pPr>
-            <a:r>
-              <a:rPr lang="fr-FR" sz="2400" dirty="0"/>
-              <a:t>Troupeau : Ankole Cattle (CC-BY) - cornes en lyre caracteristiques, plusieurs robes</a:t>
-            </a:r>
-          </a:p>
-          <a:p>
-            <a:pPr marL="342900" indent="-342900">
-              <a:buFont typeface="Arial"/>
-              <a:buChar char="-u{2022}-"/>
-            </a:pPr>
-            <a:r>
-              <a:rPr lang="fr-FR" sz="2400" dirty="0"/>
-              <a:t>Feu anime et textures de particules reelles ; chaque asset documente avec sa licence</a:t>
-            </a:r>
-          </a:p>
-        </p:txBody>
-      </p:sp>
+            <a:off x="457200" y="1700000"/>
+            <a:ext cx="5486400" cy="4800000"/>
+          </a:xfrm>
+        </p:spPr>
+        <p:txBody>
+          <a:bodyPr/>
+          <a:lstStyle/>
+          <a:p>
+            <a:pPr marL="285750" indent="-285750">
+              <a:buFont typeface="Arial"/>
+              <a:buChar char="•"/>
+            </a:pPr>
+            <a:r>
+              <a:rPr lang="fr-FR" sz="1700" dirty="0"/>
+              <a:t>Troupeau : d'abord un zebu procedural, puis 'Brahman Bull Zebu' (maximorengifo2022, Sketchfab, CC-BY-4.0), remplace ensuite par 'Ankole Cattle' (kenchoo, Sketchfab) - cornes en lyre caracteristiques, 3 robes blanche/rousse/noire</a:t>
+            </a:r>
+          </a:p>
+          <a:p>
+            <a:pPr marL="285750" indent="-285750">
+              <a:buFont typeface="Arial"/>
+              <a:buChar char="•"/>
+            </a:pPr>
+            <a:r>
+              <a:rPr lang="fr-FR" sz="1700" dirty="0"/>
+              <a:t>Joueur et PNJ : base CC0 'Human Basemeshes' redimensionnee (1.78 m / 1.75 m), habillee de primitives Blender (boubou indigo + chapeau de paille pour le berger, boubou ocre + foulard pour la femme)</a:t>
+            </a:r>
+          </a:p>
+          <a:p>
+            <a:pPr marL="285750" indent="-285750">
+              <a:buFont typeface="Arial"/>
+              <a:buChar char="•"/>
+            </a:pPr>
+            <a:r>
+              <a:rPr lang="fr-FR" sz="1700" dirty="0"/>
+              <a:t>Foyer : particules generiques -&gt; textures reelles (Kenney Particle Pack, CC0) -&gt; maillage anime 'Animated Fire' (Yannick Deharo, Sketchfab, CC-BY-4.0)</a:t>
+            </a:r>
+          </a:p>
+        </p:txBody>
+      </p:sp>
+      <p:pic>
+        <p:nvPicPr>
+          <p:cNvPr id="10" name="Picture"/>
+          <p:cNvPicPr>
+            <a:picLocks noChangeAspect="1"/>
+          </p:cNvPicPr>
+          <p:nvPr/>
+        </p:nvPicPr>
+        <p:blipFill>
+          <a:blip r:embed="rIdImg1"/>
+          <a:stretch>
+            <a:fillRect/>
+          </a:stretch>
+        </p:blipFill>
+        <p:spPr>
+          <a:xfrm>
+            <a:off x="6200775" y="1900000"/>
+            <a:ext cx="5486400" cy="3086550"/>
+          </a:xfrm>
+          <a:prstGeom prst="rect">
+            <a:avLst/>
+          </a:prstGeom>
+          <a:ln w="19050">
+            <a:solidFill>
+              <a:srgbClr val="6B3E1E"/>
+            </a:solidFill>
+          </a:ln>
+        </p:spPr>
+      </p:pic>
     </p:spTree>
   </p:cSld>
   <p:clrMapOvr>
@@ -1585,45 +1902,74 @@
         </p:nvSpPr>
         <p:spPr>
           <a:xfrm>
-            <a:off x="838200" y="1700000"/>
-            <a:ext cx="10515600" cy="4700000"/>
-          </a:xfrm>
-        </p:spPr>
-        <p:txBody>
-          <a:bodyPr/>
-          <a:lstStyle/>
-          <a:p>
-            <a:pPr marL="342900" indent="-342900">
-              <a:buFont typeface="Arial"/>
-              <a:buChar char="-u{2022}-"/>
-            </a:pPr>
-            <a:r>
-              <a:rPr lang="fr-FR" sz="2400" dirty="0"/>
-              <a:t>Boire au canari, piler le mil, s'asseoir sur la natte, prier (Dudal), examiner (grenier)</a:t>
-            </a:r>
-          </a:p>
-          <a:p>
-            <a:pPr marL="342900" indent="-342900">
-              <a:buFont typeface="Arial"/>
-              <a:buChar char="-u{2022}-"/>
-            </a:pPr>
-            <a:r>
-              <a:rPr lang="fr-FR" sz="2400" dirty="0"/>
-              <a:t>Caresser le troupeau (retour sonore dedie), attiser le feu du foyer</a:t>
-            </a:r>
-          </a:p>
-          <a:p>
-            <a:pPr marL="342900" indent="-342900">
-              <a:buFont typeface="Arial"/>
-              <a:buChar char="-u{2022}-"/>
-            </a:pPr>
-            <a:r>
-              <a:rPr lang="fr-FR" sz="2400" dirty="0"/>
-              <a:t>PNJ avec dialogue vocal - lignes audio enregistrees</a:t>
-            </a:r>
-          </a:p>
-        </p:txBody>
-      </p:sp>
+            <a:off x="457200" y="1700000"/>
+            <a:ext cx="5486400" cy="4800000"/>
+          </a:xfrm>
+        </p:spPr>
+        <p:txBody>
+          <a:bodyPr/>
+          <a:lstStyle/>
+          <a:p>
+            <a:pPr marL="285750" indent="-285750">
+              <a:buFont typeface="Arial"/>
+              <a:buChar char="•"/>
+            </a:pPr>
+            <a:r>
+              <a:rPr lang="fr-FR" sz="1700" dirty="0"/>
+              <a:t>Boire au canari, piler le mil (mortier + pilon), s'asseoir sur la natte, prier sur le Dudal, examiner (grenier - legende culturelle courte)</a:t>
+            </a:r>
+          </a:p>
+          <a:p>
+            <a:pPr marL="285750" indent="-285750">
+              <a:buFont typeface="Arial"/>
+              <a:buChar char="•"/>
+            </a:pPr>
+            <a:r>
+              <a:rPr lang="fr-FR" sz="1700" dirty="0"/>
+              <a:t>Caresser le troupeau (son dedie, extrait d'un enregistrement reel de troupeau au paturage), attiser le feu (Campement)</a:t>
+            </a:r>
+          </a:p>
+          <a:p>
+            <a:pPr marL="285750" indent="-285750">
+              <a:buFont typeface="Arial"/>
+              <a:buChar char="•"/>
+            </a:pPr>
+            <a:r>
+              <a:rPr lang="fr-FR" sz="1700" dirty="0"/>
+              <a:t>Chaque interaction : touche E, delai de rejeu, message contextuel affiche a l'ecran</a:t>
+            </a:r>
+          </a:p>
+        </p:txBody>
+      </p:sp>
+      <p:pic>
+        <p:nvPicPr>
+          <p:cNvPr id="10" name="Picture"/>
+          <p:cNvPicPr>
+            <a:picLocks noChangeAspect="1"/>
+          </p:cNvPicPr>
+          <p:nvPr/>
+        </p:nvPicPr>
+        <p:blipFill>
+          <a:blip r:embed="rIdImg1"/>
+          <a:stretch>
+            <a:fillRect/>
+          </a:stretch>
+        </p:blipFill>
+        <p:spPr>
+          <a:xfrm>
+            <a:off x="6200775" y="1900000"/>
+            <a:ext cx="5486400" cy="3086550"/>
+          </a:xfrm>
+          <a:prstGeom prst="rect">
+            <a:avLst/>
+          </a:prstGeom>
+          <a:ln w="19050">
+            <a:solidFill>
+              <a:srgbClr val="6B3E1E"/>
+            </a:solidFill>
+          </a:ln>
+        </p:spPr>
+      </p:pic>
     </p:spTree>
   </p:cSld>
   <p:clrMapOvr>

</xml_diff>